<commit_message>
Klaster 1: dokumen Telaah dikembalikan apa adanya, slide dan HTML mengikuti dokumen
Dokumen Word tidak disunting. Slide memakai file asli (animasi utuh) dengan
dua perubahan kecil agar sama dengan dokumen. Data interaktif dipakai apa
adanya karena sudah cocok dengan Lampiran I.

Co-Authored-By: Claude Fable 5.1 <noreply@anthropic.com>
Claude-Session: https://claude.ai/code/session_01YRzsgeieNDAiMxdefdbbP3
</commit_message>
<xml_diff>
--- a/presentasi/klaster1/BHP Medan - Klaster 1 Tumpang Tindih Kewenangan - Paparan.pptx
+++ b/presentasi/klaster1/BHP Medan - Klaster 1 Tumpang Tindih Kewenangan - Paparan.pptx
@@ -1557,7 +1557,7 @@
                   <a:srgbClr val="2B2B2B"/>
                 </a:solidFill>
               </a:rPr>
-              <a:t>Kendalanya muncul saat kurator BHP bekerja bersama kurator perseorangan: belum ada pembagian imbalan dan tanggung jawab, serah terima saat PKPU berakhir pailit, dan satu standar profesi.</a:t>
+              <a:t>Yang </a:t>
             </a:r>
             <a:r>
               <a:rPr lang="en-US" sz="1100" dirty="0" err="1">
@@ -1565,7 +1565,7 @@
                   <a:srgbClr val="2B2B2B"/>
                 </a:solidFill>
               </a:rPr>
-              <a:t/>
+              <a:t>menjadi</a:t>
             </a:r>
             <a:r>
               <a:rPr lang="en-US" sz="1100" dirty="0">
@@ -1573,7 +1573,7 @@
                   <a:srgbClr val="2B2B2B"/>
                 </a:solidFill>
               </a:rPr>
-              <a:t/>
+              <a:t> </a:t>
             </a:r>
             <a:r>
               <a:rPr lang="en-US" sz="1100" dirty="0" err="1">
@@ -1581,7 +1581,7 @@
                   <a:srgbClr val="2B2B2B"/>
                 </a:solidFill>
               </a:rPr>
-              <a:t/>
+              <a:t>kendala</a:t>
             </a:r>
             <a:r>
               <a:rPr lang="en-US" sz="1100" dirty="0">
@@ -1589,7 +1589,7 @@
                   <a:srgbClr val="2B2B2B"/>
                 </a:solidFill>
               </a:rPr>
-              <a:t/>
+              <a:t> </a:t>
             </a:r>
             <a:r>
               <a:rPr lang="en-US" sz="1100" dirty="0" err="1">
@@ -1597,7 +1597,7 @@
                   <a:srgbClr val="2B2B2B"/>
                 </a:solidFill>
               </a:rPr>
-              <a:t/>
+              <a:t>adalah</a:t>
             </a:r>
             <a:r>
               <a:rPr lang="en-US" sz="1100" dirty="0">
@@ -1605,7 +1605,7 @@
                   <a:srgbClr val="2B2B2B"/>
                 </a:solidFill>
               </a:rPr>
-              <a:t/>
+              <a:t> </a:t>
             </a:r>
             <a:r>
               <a:rPr lang="en-US" sz="1100" dirty="0" err="1">
@@ -1613,7 +1613,7 @@
                   <a:srgbClr val="2B2B2B"/>
                 </a:solidFill>
               </a:rPr>
-              <a:t/>
+              <a:t>ketika</a:t>
             </a:r>
             <a:r>
               <a:rPr lang="en-US" sz="1100" dirty="0">
@@ -1621,7 +1621,7 @@
                   <a:srgbClr val="2B2B2B"/>
                 </a:solidFill>
               </a:rPr>
-              <a:t/>
+              <a:t> </a:t>
             </a:r>
             <a:r>
               <a:rPr lang="en-US" sz="1100" dirty="0" err="1">
@@ -1629,7 +1629,7 @@
                   <a:srgbClr val="2B2B2B"/>
                 </a:solidFill>
               </a:rPr>
-              <a:t/>
+              <a:t>kurator</a:t>
             </a:r>
             <a:r>
               <a:rPr lang="en-US" sz="1100" dirty="0">
@@ -1637,7 +1637,7 @@
                   <a:srgbClr val="2B2B2B"/>
                 </a:solidFill>
               </a:rPr>
-              <a:t/>
+              <a:t> BHP </a:t>
             </a:r>
             <a:r>
               <a:rPr lang="en-US" sz="1100" dirty="0" err="1">
@@ -1645,7 +1645,7 @@
                   <a:srgbClr val="2B2B2B"/>
                 </a:solidFill>
               </a:rPr>
-              <a:t/>
+              <a:t>bekerja</a:t>
             </a:r>
             <a:r>
               <a:rPr lang="en-US" sz="1100" dirty="0">
@@ -1653,7 +1653,7 @@
                   <a:srgbClr val="2B2B2B"/>
                 </a:solidFill>
               </a:rPr>
-              <a:t/>
+              <a:t> </a:t>
             </a:r>
             <a:r>
               <a:rPr lang="en-US" sz="1100" dirty="0" err="1">
@@ -1661,7 +1661,7 @@
                   <a:srgbClr val="2B2B2B"/>
                 </a:solidFill>
               </a:rPr>
-              <a:t/>
+              <a:t>sama</a:t>
             </a:r>
             <a:r>
               <a:rPr lang="en-US" sz="1100" dirty="0">
@@ -1669,7 +1669,7 @@
                   <a:srgbClr val="2B2B2B"/>
                 </a:solidFill>
               </a:rPr>
-              <a:t/>
+              <a:t> </a:t>
             </a:r>
             <a:r>
               <a:rPr lang="en-US" sz="1100" dirty="0" err="1">
@@ -1677,7 +1677,7 @@
                   <a:srgbClr val="2B2B2B"/>
                 </a:solidFill>
               </a:rPr>
-              <a:t/>
+              <a:t>dengan</a:t>
             </a:r>
             <a:r>
               <a:rPr lang="en-US" sz="1100" dirty="0">
@@ -1685,7 +1685,7 @@
                   <a:srgbClr val="2B2B2B"/>
                 </a:solidFill>
               </a:rPr>
-              <a:t/>
+              <a:t> </a:t>
             </a:r>
             <a:r>
               <a:rPr lang="en-US" sz="1100" dirty="0" err="1">
@@ -1693,7 +1693,7 @@
                   <a:srgbClr val="2B2B2B"/>
                 </a:solidFill>
               </a:rPr>
-              <a:t/>
+              <a:t>kurator</a:t>
             </a:r>
             <a:r>
               <a:rPr lang="en-US" sz="1100" dirty="0">
@@ -1701,7 +1701,7 @@
                   <a:srgbClr val="2B2B2B"/>
                 </a:solidFill>
               </a:rPr>
-              <a:t/>
+              <a:t> </a:t>
             </a:r>
             <a:r>
               <a:rPr lang="en-US" sz="1100" dirty="0" err="1">
@@ -1709,7 +1709,7 @@
                   <a:srgbClr val="2B2B2B"/>
                 </a:solidFill>
               </a:rPr>
-              <a:t/>
+              <a:t>perseorangan</a:t>
             </a:r>
             <a:r>
               <a:rPr lang="en-US" sz="1100" dirty="0">
@@ -1717,8 +1717,105 @@
                   <a:srgbClr val="2B2B2B"/>
                 </a:solidFill>
               </a:rPr>
-              <a:t/>
-            </a:r>
+              <a:t>.</a:t>
+            </a:r>
+          </a:p>
+          <a:p>
+            <a:pPr marL="0" indent="0">
+              <a:spcAft>
+                <a:spcPts val="250"/>
+              </a:spcAft>
+              <a:buNone/>
+            </a:pPr>
+            <a:r>
+              <a:rPr lang="en-US" sz="1100" dirty="0">
+                <a:solidFill>
+                  <a:srgbClr val="2B2B2B"/>
+                </a:solidFill>
+              </a:rPr>
+              <a:t>Belum </a:t>
+            </a:r>
+            <a:r>
+              <a:rPr lang="en-US" sz="1100" dirty="0" err="1">
+                <a:solidFill>
+                  <a:srgbClr val="2B2B2B"/>
+                </a:solidFill>
+              </a:rPr>
+              <a:t>ada</a:t>
+            </a:r>
+            <a:r>
+              <a:rPr lang="en-US" sz="1100" dirty="0">
+                <a:solidFill>
+                  <a:srgbClr val="2B2B2B"/>
+                </a:solidFill>
+              </a:rPr>
+              <a:t> </a:t>
+            </a:r>
+            <a:r>
+              <a:rPr lang="en-US" sz="1100" dirty="0" err="1">
+                <a:solidFill>
+                  <a:srgbClr val="2B2B2B"/>
+                </a:solidFill>
+              </a:rPr>
+              <a:t>pembagian</a:t>
+            </a:r>
+            <a:r>
+              <a:rPr lang="en-US" sz="1100" dirty="0">
+                <a:solidFill>
+                  <a:srgbClr val="2B2B2B"/>
+                </a:solidFill>
+              </a:rPr>
+              <a:t> imbalan dan </a:t>
+            </a:r>
+            <a:r>
+              <a:rPr lang="en-US" sz="1100" dirty="0" err="1">
+                <a:solidFill>
+                  <a:srgbClr val="2B2B2B"/>
+                </a:solidFill>
+              </a:rPr>
+              <a:t>tanggung</a:t>
+            </a:r>
+            <a:r>
+              <a:rPr lang="en-US" sz="1100" dirty="0">
+                <a:solidFill>
+                  <a:srgbClr val="2B2B2B"/>
+                </a:solidFill>
+              </a:rPr>
+              <a:t> </a:t>
+            </a:r>
+            <a:r>
+              <a:rPr lang="en-US" sz="1100" dirty="0" err="1">
+                <a:solidFill>
+                  <a:srgbClr val="2B2B2B"/>
+                </a:solidFill>
+              </a:rPr>
+              <a:t>jawab</a:t>
+            </a:r>
+            <a:r>
+              <a:rPr lang="en-US" sz="1100" dirty="0">
+                <a:solidFill>
+                  <a:srgbClr val="2B2B2B"/>
+                </a:solidFill>
+              </a:rPr>
+              <a:t> yang </a:t>
+            </a:r>
+            <a:r>
+              <a:rPr lang="en-US" sz="1100" dirty="0" err="1">
+                <a:solidFill>
+                  <a:srgbClr val="2B2B2B"/>
+                </a:solidFill>
+              </a:rPr>
+              <a:t>jelas</a:t>
+            </a:r>
+            <a:r>
+              <a:rPr lang="en-US" sz="1100" dirty="0">
+                <a:solidFill>
+                  <a:srgbClr val="2B2B2B"/>
+                </a:solidFill>
+              </a:rPr>
+              <a:t>, serah terima dari PKPU, dan standar profesi yang sama.</a:t>
+            </a:r>
+            <a:endParaRPr lang="en-US" sz="1100" dirty="0"/>
           </a:p>
         </p:txBody>
       </p:sp>
@@ -7601,7 +7698,7 @@
                   <a:srgbClr val="2B2B2B"/>
                 </a:solidFill>
               </a:rPr>
-              <a:t>Satu standar profesi bagi BHP dan kurator perseorangan; kode etik mengikuti jalur masing-masing (ASN untuk BHP, organisasi profesi untuk kurator perseorangan).</a:t>
+              <a:t>Satu standar profesi dan kode etik bagi BHP dan kurator perseorangan.</a:t>
             </a:r>
             <a:endParaRPr lang="en-US" sz="1200" dirty="0"/>
           </a:p>

</xml_diff>

<commit_message>
Klaster 1: samakan dengan Data Pendukung final (BHP ditunjuk 1 dari 16)
- PPT animasi: "2 dari 9" menjadi "1 dari 9"; bukti SIPP menyebut BHP ditunjuk
  1 kali dan 1 perkara dalam kasasi; "mengangkat" menjadi "menunjuk". Transisi,
  morph, dan animasi tidak berubah.
- Data interaktif dan Vercel /data memakai dashboard terbaru dari situs GitHub
  Pages, termasuk grafik alur perkara bergerak di tab Pembuka; data-lengkap,
  fonts, logo, dan PPTX ikut disalin.
- Data Pendukung final disimpan sebagai acuan.

Co-Authored-By: Claude Opus 5.5 <noreply@anthropic.com>
Claude-Session: https://claude.ai/code/session_01YRzsgeieNDAiMxdefdbbP3
</commit_message>
<xml_diff>
--- a/presentasi/klaster1/BHP Medan - Klaster 1 Tumpang Tindih Kewenangan - Paparan.pptx
+++ b/presentasi/klaster1/BHP Medan - Klaster 1 Tumpang Tindih Kewenangan - Paparan.pptx
@@ -2895,7 +2895,7 @@
                   <a:srgbClr val="2B2B2B"/>
                 </a:solidFill>
               </a:rPr>
-              <a:t>SIPP 2025 s.d. 2026: dari 16 putusan pailit, BHP hanya diangkat 2 kali, keduanya karena diminta pemohon. Penugasan BHP masih bergantung pada pilihan pemohon.</a:t>
+              <a:t>SIPP 2025 s.d. 2026: dari 16 putusan pailit, BHP hanya ditunjuk 1 kali, atas permintaan pemohon; 1 perkara lain dalam kasasi. Penugasan BHP masih bergantung pada pemohon.</a:t>
             </a:r>
             <a:endParaRPr lang="en-US" sz="1050" dirty="0"/>
           </a:p>
@@ -3243,7 +3243,7 @@
                 <a:ea typeface="Cambria" pitchFamily="34" charset="-122"/>
                 <a:cs typeface="Cambria" pitchFamily="34" charset="-120"/>
               </a:rPr>
-              <a:t>2 dari 9</a:t>
+              <a:t>1 dari 9</a:t>
             </a:r>
             <a:endParaRPr lang="en-US" sz="2200" dirty="0"/>
           </a:p>
@@ -3279,7 +3279,7 @@
                   <a:srgbClr val="FFFFFF"/>
                 </a:solidFill>
               </a:rPr>
-              <a:t>putusan pailit 2025 mengangkat BHP</a:t>
+              <a:t>putusan pailit 2025 menunjuk BHP</a:t>
             </a:r>
             <a:endParaRPr lang="en-US" sz="1150" dirty="0"/>
           </a:p>
@@ -3354,7 +3354,7 @@
                   <a:srgbClr val="FFFFFF"/>
                 </a:solidFill>
               </a:rPr>
-              <a:t>putusan pailit 2026 mengangkat BHP</a:t>
+              <a:t>putusan pailit 2026 menunjuk BHP</a:t>
             </a:r>
             <a:endParaRPr lang="en-US" sz="1150" dirty="0"/>
           </a:p>
@@ -7422,7 +7422,7 @@
                   <a:srgbClr val="2B2B2B"/>
                 </a:solidFill>
               </a:rPr>
-              <a:t>Pengadilan wajib mengangkat BHP bila debitor meninggal tanpa ahli waris atau hartanya tak terurus, tidak diketahui keberadaannya, ahli waris masih anak atau dalam pengampuan, permohonan diajukan pekerja, atau perkara kehilangan kurator.</a:t>
+              <a:t>Pengadilan wajib menunjuk BHP bila debitor meninggal tanpa ahli waris atau hartanya tak terurus, tidak diketahui keberadaannya, ahli waris masih anak atau dalam pengampuan, permohonan diajukan pekerja, atau perkara kehilangan kurator.</a:t>
             </a:r>
             <a:endParaRPr lang="en-US" sz="1200" dirty="0"/>
           </a:p>
@@ -8534,7 +8534,7 @@
                   <a:srgbClr val="F1DCDF"/>
                 </a:solidFill>
               </a:rPr>
-              <a:t>mengangkat kurator dan menyampaikan putusan</a:t>
+              <a:t>menunjuk kurator dan menyampaikan putusan</a:t>
             </a:r>
             <a:endParaRPr lang="en-US" sz="1050" dirty="0"/>
           </a:p>

</xml_diff>

<commit_message>
Paparan Klaster 1: perjelas 16 putusan pailit dari 109 permohonan
Co-Authored-By: Claude Opus 5.5 <noreply@anthropic.com>
Claude-Session: https://claude.ai/code/session_01YRzsgeieNDAiMxdefdbbP3
</commit_message>
<xml_diff>
--- a/presentasi/klaster1/BHP Medan - Klaster 1 Tumpang Tindih Kewenangan - Paparan.pptx
+++ b/presentasi/klaster1/BHP Medan - Klaster 1 Tumpang Tindih Kewenangan - Paparan.pptx
@@ -2895,7 +2895,7 @@
                   <a:srgbClr val="2B2B2B"/>
                 </a:solidFill>
               </a:rPr>
-              <a:t>SIPP 2025 s.d. 2026: dari 16 putusan pailit, BHP hanya ditunjuk 1 kali, atas permintaan pemohon; 1 perkara lain dalam kasasi. Penugasan BHP masih bergantung pada pemohon.</a:t>
+              <a:t>SIPP 2025 s.d. 2026: dari 109 permohonan pailit dan PKPU, 16 berakhir putusan pailit; BHP hanya ditunjuk 1 kali, atas permintaan pemohon; 1 perkara lain dalam kasasi. Penugasan BHP masih bergantung pada pemohon.</a:t>
             </a:r>
             <a:endParaRPr lang="en-US" sz="1050" dirty="0"/>
           </a:p>
@@ -3390,7 +3390,7 @@
                   <a:srgbClr val="6B6B6B"/>
                 </a:solidFill>
               </a:rPr>
-              <a:t>Sumber: Buku Register Kepailitan dan laporan pengurusan BHP Medan; SIPP PN Medan per 2 Oktober 2026, diolah.</a:t>
+              <a:t>Sumber: Buku Register Kepailitan dan laporan pengurusan BHP Medan; SIPP PN Medan per 2 Oktober 2026, diolah. Dihitung per putusan pailit, bukan per permohonan.</a:t>
             </a:r>
             <a:endParaRPr lang="en-US" sz="900" dirty="0"/>
           </a:p>

</xml_diff>